<commit_message>
Update portfolio with 5 client galleries and Google Drive refs
Replace generic categories with actual clients:
- Brother Printer, CSA, GY Beauty, iQiYi, Zontes
- Each gallery slide includes Drive folder link for photo sourcing
- Services slide updated to "Our Clients" with 5-client grid layout
- 11 slides total (was 10)

https://claude.ai/code/session_01891GEHpjg9rZTP1hHp8RDY
</commit_message>
<xml_diff>
--- a/Event_Photo_Portfolio.pptx
+++ b/Event_Photo_Portfolio.pptx
@@ -15,6 +15,7 @@
     <p:sldId id="263" r:id="rId14"/>
     <p:sldId id="264" r:id="rId15"/>
     <p:sldId id="265" r:id="rId16"/>
+    <p:sldId id="266" r:id="rId17"/>
   </p:sldIdLst>
   <p:sldSz cx="12191695" cy="6858000" type="screen4x3"/>
   <p:notesSz cx="6858000" cy="9144000"/>
@@ -3326,6 +3327,176 @@
         </p:nvSpPr>
         <p:spPr>
           <a:xfrm>
+            <a:off x="914400" y="914400"/>
+            <a:ext cx="914400" cy="1371600"/>
+          </a:xfrm>
+          <a:prstGeom prst="rect">
+            <a:avLst/>
+          </a:prstGeom>
+          <a:noFill/>
+        </p:spPr>
+        <p:txBody>
+          <a:bodyPr wrap="square">
+            <a:spAutoFit/>
+          </a:bodyPr>
+          <a:lstStyle/>
+          <a:p>
+            <a:pPr algn="l">
+              <a:defRPr sz="9600" b="1">
+                <a:solidFill>
+                  <a:srgbClr val="C8A26E"/>
+                </a:solidFill>
+                <a:latin typeface="Calibri Light"/>
+              </a:defRPr>
+            </a:pPr>
+            <a:r>
+              <a:t>“</a:t>
+            </a:r>
+          </a:p>
+        </p:txBody>
+      </p:sp>
+      <p:sp>
+        <p:nvSpPr>
+          <p:cNvPr id="3" name="TextBox 2"/>
+          <p:cNvSpPr txBox="1"/>
+          <p:nvPr/>
+        </p:nvSpPr>
+        <p:spPr>
+          <a:xfrm>
+            <a:off x="1828800" y="2011680"/>
+            <a:ext cx="8229600" cy="2286000"/>
+          </a:xfrm>
+          <a:prstGeom prst="rect">
+            <a:avLst/>
+          </a:prstGeom>
+          <a:noFill/>
+        </p:spPr>
+        <p:txBody>
+          <a:bodyPr wrap="square">
+            <a:spAutoFit/>
+          </a:bodyPr>
+          <a:lstStyle/>
+          <a:p>
+            <a:pPr algn="ctr">
+              <a:defRPr sz="2000" b="0">
+                <a:solidFill>
+                  <a:srgbClr val="FFFFFF"/>
+                </a:solidFill>
+                <a:latin typeface="Calibri Light"/>
+              </a:defRPr>
+            </a:pPr>
+            <a:r>
+              <a:t>Absolutely phenomenal work. Every single photo captured the energy and emotion of our event perfectly. We couldn't have asked for a better photographer. Highly recommend!</a:t>
+            </a:r>
+          </a:p>
+        </p:txBody>
+      </p:sp>
+      <p:sp>
+        <p:nvSpPr>
+          <p:cNvPr id="4" name="TextBox 3"/>
+          <p:cNvSpPr txBox="1"/>
+          <p:nvPr/>
+        </p:nvSpPr>
+        <p:spPr>
+          <a:xfrm>
+            <a:off x="1828800" y="4389120"/>
+            <a:ext cx="8229600" cy="457200"/>
+          </a:xfrm>
+          <a:prstGeom prst="rect">
+            <a:avLst/>
+          </a:prstGeom>
+          <a:noFill/>
+        </p:spPr>
+        <p:txBody>
+          <a:bodyPr wrap="square">
+            <a:spAutoFit/>
+          </a:bodyPr>
+          <a:lstStyle/>
+          <a:p>
+            <a:pPr algn="ctr">
+              <a:defRPr sz="1400" b="0">
+                <a:solidFill>
+                  <a:srgbClr val="AAAAAA"/>
+                </a:solidFill>
+                <a:latin typeface="Calibri Light"/>
+              </a:defRPr>
+            </a:pPr>
+            <a:r>
+              <a:t>— [Client Name], [Event Name]</a:t>
+            </a:r>
+          </a:p>
+        </p:txBody>
+      </p:sp>
+      <p:sp>
+        <p:nvSpPr>
+          <p:cNvPr id="5" name="TextBox 4"/>
+          <p:cNvSpPr txBox="1"/>
+          <p:nvPr/>
+        </p:nvSpPr>
+        <p:spPr>
+          <a:xfrm>
+            <a:off x="1828800" y="5303520"/>
+            <a:ext cx="8229600" cy="365760"/>
+          </a:xfrm>
+          <a:prstGeom prst="rect">
+            <a:avLst/>
+          </a:prstGeom>
+          <a:noFill/>
+        </p:spPr>
+        <p:txBody>
+          <a:bodyPr wrap="square">
+            <a:spAutoFit/>
+          </a:bodyPr>
+          <a:lstStyle/>
+          <a:p>
+            <a:pPr algn="ctr">
+              <a:defRPr sz="1100" b="0">
+                <a:solidFill>
+                  <a:srgbClr val="555555"/>
+                </a:solidFill>
+                <a:latin typeface="Calibri Light"/>
+              </a:defRPr>
+            </a:pPr>
+            <a:r>
+              <a:t>[Add more testimonials as needed]</a:t>
+            </a:r>
+          </a:p>
+        </p:txBody>
+      </p:sp>
+    </p:spTree>
+  </p:cSld>
+  <p:clrMapOvr>
+    <a:masterClrMapping/>
+  </p:clrMapOvr>
+</p:sld>
+</file>
+
+<file path=ppt/slides/slide11.xml><?xml version="1.0" encoding="utf-8"?>
+<p:sld xmlns:a="http://schemas.openxmlformats.org/drawingml/2006/main" xmlns:p="http://schemas.openxmlformats.org/presentationml/2006/main" xmlns:r="http://schemas.openxmlformats.org/officeDocument/2006/relationships">
+  <p:cSld>
+    <p:bg>
+      <p:bgPr>
+        <a:solidFill>
+          <a:srgbClr val="1A1A1A"/>
+        </a:solidFill>
+        <a:effectLst/>
+      </p:bgPr>
+    </p:bg>
+    <p:spTree>
+      <p:nvGrpSpPr>
+        <p:cNvPr id="1" name=""/>
+        <p:cNvGrpSpPr/>
+        <p:nvPr/>
+      </p:nvGrpSpPr>
+      <p:grpSpPr/>
+      <p:sp>
+        <p:nvSpPr>
+          <p:cNvPr id="2" name="TextBox 1"/>
+          <p:cNvSpPr txBox="1"/>
+          <p:nvPr/>
+        </p:nvSpPr>
+        <p:spPr>
+          <a:xfrm>
             <a:off x="914400" y="1371600"/>
             <a:ext cx="10058400" cy="731520"/>
           </a:xfrm>
@@ -3752,7 +3923,7 @@
               </a:defRPr>
             </a:pPr>
             <a:r>
-              <a:t>WHAT I COVER</a:t>
+              <a:t>OUR CLIENTS</a:t>
             </a:r>
           </a:p>
         </p:txBody>
@@ -3808,8 +3979,8 @@
         </p:nvSpPr>
         <p:spPr>
           <a:xfrm>
-            <a:off x="548640" y="1828800"/>
-            <a:ext cx="2560320" cy="2560320"/>
+            <a:off x="548640" y="1645920"/>
+            <a:ext cx="3291840" cy="2194560"/>
           </a:xfrm>
           <a:prstGeom prst="rect">
             <a:avLst/>
@@ -3853,7 +4024,7 @@
               </a:defRPr>
             </a:pPr>
             <a:r>
-              <a:t>[Weddings &amp; Social Events Photo]</a:t>
+              <a:t>[Brother Printer — Best Shot]</a:t>
             </a:r>
           </a:p>
         </p:txBody>
@@ -3866,8 +4037,8 @@
         </p:nvSpPr>
         <p:spPr>
           <a:xfrm>
-            <a:off x="548640" y="4572000"/>
-            <a:ext cx="2560320" cy="457200"/>
+            <a:off x="548640" y="3931920"/>
+            <a:ext cx="3291840" cy="457200"/>
           </a:xfrm>
           <a:prstGeom prst="rect">
             <a:avLst/>
@@ -3889,7 +4060,7 @@
               </a:defRPr>
             </a:pPr>
             <a:r>
-              <a:t>Weddings &amp; Social Events</a:t>
+              <a:t>Brother Printer</a:t>
             </a:r>
           </a:p>
         </p:txBody>
@@ -3902,8 +4073,8 @@
         </p:nvSpPr>
         <p:spPr>
           <a:xfrm>
-            <a:off x="548640" y="4937760"/>
-            <a:ext cx="2560320" cy="731520"/>
+            <a:off x="548640" y="4297680"/>
+            <a:ext cx="3291840" cy="731520"/>
           </a:xfrm>
           <a:prstGeom prst="rect">
             <a:avLst/>
@@ -3925,11 +4096,11 @@
               </a:defRPr>
             </a:pPr>
             <a:r>
-              <a:t>Engagements, receptions,</a:t>
+              <a:t>Product launches, corporate</a:t>
             </a:r>
             <a:br/>
             <a:r>
-              <a:t>birthdays, anniversaries</a:t>
+              <a:t>activations &amp; brand events</a:t>
             </a:r>
           </a:p>
         </p:txBody>
@@ -3942,8 +4113,8 @@
         </p:nvSpPr>
         <p:spPr>
           <a:xfrm>
-            <a:off x="3429000" y="1828800"/>
-            <a:ext cx="2560320" cy="2560320"/>
+            <a:off x="4297679" y="1645920"/>
+            <a:ext cx="3291840" cy="2194560"/>
           </a:xfrm>
           <a:prstGeom prst="rect">
             <a:avLst/>
@@ -3987,7 +4158,7 @@
               </a:defRPr>
             </a:pPr>
             <a:r>
-              <a:t>[Corporate &amp; Conferences Photo]</a:t>
+              <a:t>[CSA — Best Shot]</a:t>
             </a:r>
           </a:p>
         </p:txBody>
@@ -4000,8 +4171,8 @@
         </p:nvSpPr>
         <p:spPr>
           <a:xfrm>
-            <a:off x="3429000" y="4572000"/>
-            <a:ext cx="2560320" cy="457200"/>
+            <a:off x="4297679" y="3931920"/>
+            <a:ext cx="3291840" cy="457200"/>
           </a:xfrm>
           <a:prstGeom prst="rect">
             <a:avLst/>
@@ -4023,7 +4194,7 @@
               </a:defRPr>
             </a:pPr>
             <a:r>
-              <a:t>Corporate &amp; Conferences</a:t>
+              <a:t>CSA</a:t>
             </a:r>
           </a:p>
         </p:txBody>
@@ -4036,8 +4207,8 @@
         </p:nvSpPr>
         <p:spPr>
           <a:xfrm>
-            <a:off x="3429000" y="4937760"/>
-            <a:ext cx="2560320" cy="731520"/>
+            <a:off x="4297679" y="4297680"/>
+            <a:ext cx="3291840" cy="731520"/>
           </a:xfrm>
           <a:prstGeom prst="rect">
             <a:avLst/>
@@ -4059,11 +4230,11 @@
               </a:defRPr>
             </a:pPr>
             <a:r>
-              <a:t>Summits, product launches,</a:t>
+              <a:t>Community events,</a:t>
             </a:r>
             <a:br/>
             <a:r>
-              <a:t>trade shows, galas</a:t>
+              <a:t>association gatherings</a:t>
             </a:r>
           </a:p>
         </p:txBody>
@@ -4076,8 +4247,8 @@
         </p:nvSpPr>
         <p:spPr>
           <a:xfrm>
-            <a:off x="6309359" y="1828800"/>
-            <a:ext cx="2560320" cy="2560320"/>
+            <a:off x="8046719" y="1645920"/>
+            <a:ext cx="3291840" cy="2194560"/>
           </a:xfrm>
           <a:prstGeom prst="rect">
             <a:avLst/>
@@ -4121,7 +4292,7 @@
               </a:defRPr>
             </a:pPr>
             <a:r>
-              <a:t>[Concerts &amp; Entertainment Photo]</a:t>
+              <a:t>[GY Beauty — Best Shot]</a:t>
             </a:r>
           </a:p>
         </p:txBody>
@@ -4134,8 +4305,8 @@
         </p:nvSpPr>
         <p:spPr>
           <a:xfrm>
-            <a:off x="6309359" y="4572000"/>
-            <a:ext cx="2560320" cy="457200"/>
+            <a:off x="8046719" y="3931920"/>
+            <a:ext cx="3291840" cy="457200"/>
           </a:xfrm>
           <a:prstGeom prst="rect">
             <a:avLst/>
@@ -4157,7 +4328,7 @@
               </a:defRPr>
             </a:pPr>
             <a:r>
-              <a:t>Concerts &amp; Entertainment</a:t>
+              <a:t>GY Beauty</a:t>
             </a:r>
           </a:p>
         </p:txBody>
@@ -4170,8 +4341,8 @@
         </p:nvSpPr>
         <p:spPr>
           <a:xfrm>
-            <a:off x="6309359" y="4937760"/>
-            <a:ext cx="2560320" cy="731520"/>
+            <a:off x="8046719" y="4297680"/>
+            <a:ext cx="3291840" cy="731520"/>
           </a:xfrm>
           <a:prstGeom prst="rect">
             <a:avLst/>
@@ -4193,11 +4364,11 @@
               </a:defRPr>
             </a:pPr>
             <a:r>
-              <a:t>Live music, festivals,</a:t>
+              <a:t>Beauty &amp; lifestyle,</a:t>
             </a:r>
             <a:br/>
             <a:r>
-              <a:t>theater, nightlife events</a:t>
+              <a:t>brand campaigns</a:t>
             </a:r>
           </a:p>
         </p:txBody>
@@ -4210,8 +4381,8 @@
         </p:nvSpPr>
         <p:spPr>
           <a:xfrm>
-            <a:off x="9189719" y="1828800"/>
-            <a:ext cx="2560320" cy="2560320"/>
+            <a:off x="2423160" y="4572000"/>
+            <a:ext cx="3291840" cy="1463040"/>
           </a:xfrm>
           <a:prstGeom prst="rect">
             <a:avLst/>
@@ -4255,7 +4426,7 @@
               </a:defRPr>
             </a:pPr>
             <a:r>
-              <a:t>[Personal &amp; Lifestyle Photo]</a:t>
+              <a:t>[iQiYi — Best Shot]</a:t>
             </a:r>
           </a:p>
         </p:txBody>
@@ -4268,8 +4439,8 @@
         </p:nvSpPr>
         <p:spPr>
           <a:xfrm>
-            <a:off x="9189719" y="4572000"/>
-            <a:ext cx="2560320" cy="457200"/>
+            <a:off x="2423160" y="6126480"/>
+            <a:ext cx="3291840" cy="365760"/>
           </a:xfrm>
           <a:prstGeom prst="rect">
             <a:avLst/>
@@ -4291,21 +4462,79 @@
               </a:defRPr>
             </a:pPr>
             <a:r>
-              <a:t>Personal &amp; Lifestyle</a:t>
-            </a:r>
-          </a:p>
-        </p:txBody>
-      </p:sp>
-      <p:sp>
-        <p:nvSpPr>
-          <p:cNvPr id="15" name="TextBox 14"/>
+              <a:t>iQiYi</a:t>
+            </a:r>
+          </a:p>
+        </p:txBody>
+      </p:sp>
+      <p:sp>
+        <p:nvSpPr>
+          <p:cNvPr id="15" name="Rectangle 14"/>
+          <p:cNvSpPr/>
+          <p:nvPr/>
+        </p:nvSpPr>
+        <p:spPr>
+          <a:xfrm>
+            <a:off x="6172200" y="4572000"/>
+            <a:ext cx="3291840" cy="1463040"/>
+          </a:xfrm>
+          <a:prstGeom prst="rect">
+            <a:avLst/>
+          </a:prstGeom>
+          <a:solidFill>
+            <a:srgbClr val="2A2A2A"/>
+          </a:solidFill>
+          <a:ln w="12700">
+            <a:solidFill>
+              <a:srgbClr val="444444"/>
+            </a:solidFill>
+          </a:ln>
+        </p:spPr>
+        <p:style>
+          <a:lnRef idx="1">
+            <a:schemeClr val="accent1"/>
+          </a:lnRef>
+          <a:fillRef idx="3">
+            <a:schemeClr val="accent1"/>
+          </a:fillRef>
+          <a:effectRef idx="2">
+            <a:schemeClr val="accent1"/>
+          </a:effectRef>
+          <a:fontRef idx="minor">
+            <a:schemeClr val="lt1"/>
+          </a:fontRef>
+        </p:style>
+        <p:txBody>
+          <a:bodyPr rtlCol="0" anchor="ctr" wrap="square"/>
+          <a:lstStyle/>
+          <a:p>
+            <a:pPr algn="ctr">
+              <a:spcBef>
+                <a:spcPts val="0"/>
+              </a:spcBef>
+              <a:defRPr sz="1100">
+                <a:solidFill>
+                  <a:srgbClr val="AAAAAA"/>
+                </a:solidFill>
+                <a:latin typeface="Calibri Light"/>
+              </a:defRPr>
+            </a:pPr>
+            <a:r>
+              <a:t>[Zontes — Best Shot]</a:t>
+            </a:r>
+          </a:p>
+        </p:txBody>
+      </p:sp>
+      <p:sp>
+        <p:nvSpPr>
+          <p:cNvPr id="16" name="TextBox 15"/>
           <p:cNvSpPr txBox="1"/>
           <p:nvPr/>
         </p:nvSpPr>
         <p:spPr>
           <a:xfrm>
-            <a:off x="9189719" y="4937760"/>
-            <a:ext cx="2560320" cy="731520"/>
+            <a:off x="6172200" y="6126480"/>
+            <a:ext cx="3291840" cy="365760"/>
           </a:xfrm>
           <a:prstGeom prst="rect">
             <a:avLst/>
@@ -4319,19 +4548,15 @@
           <a:lstStyle/>
           <a:p>
             <a:pPr algn="ctr">
-              <a:defRPr sz="1100" b="0">
-                <a:solidFill>
-                  <a:srgbClr val="AAAAAA"/>
+              <a:defRPr sz="1300" b="1">
+                <a:solidFill>
+                  <a:srgbClr val="FFFFFF"/>
                 </a:solidFill>
                 <a:latin typeface="Calibri Light"/>
               </a:defRPr>
             </a:pPr>
             <a:r>
-              <a:t>Portraits, brand shoots,</a:t>
-            </a:r>
-            <a:br/>
-            <a:r>
-              <a:t>special occasions</a:t>
+              <a:t>Zontes</a:t>
             </a:r>
           </a:p>
         </p:txBody>
@@ -4370,7 +4595,7 @@
         </p:nvSpPr>
         <p:spPr>
           <a:xfrm>
-            <a:off x="731520" y="365760"/>
+            <a:off x="731520" y="228600"/>
             <a:ext cx="10058400" cy="548640"/>
           </a:xfrm>
           <a:prstGeom prst="rect">
@@ -4393,20 +4618,56 @@
               </a:defRPr>
             </a:pPr>
             <a:r>
-              <a:t>WEDDINGS &amp; SOCIAL</a:t>
-            </a:r>
-          </a:p>
-        </p:txBody>
-      </p:sp>
-      <p:sp>
-        <p:nvSpPr>
-          <p:cNvPr id="3" name="Rectangle 2"/>
+              <a:t>BROTHER PRINTER</a:t>
+            </a:r>
+          </a:p>
+        </p:txBody>
+      </p:sp>
+      <p:sp>
+        <p:nvSpPr>
+          <p:cNvPr id="3" name="TextBox 2"/>
+          <p:cNvSpPr txBox="1"/>
+          <p:nvPr/>
+        </p:nvSpPr>
+        <p:spPr>
+          <a:xfrm>
+            <a:off x="731520" y="685800"/>
+            <a:ext cx="5486400" cy="365760"/>
+          </a:xfrm>
+          <a:prstGeom prst="rect">
+            <a:avLst/>
+          </a:prstGeom>
+          <a:noFill/>
+        </p:spPr>
+        <p:txBody>
+          <a:bodyPr wrap="square">
+            <a:spAutoFit/>
+          </a:bodyPr>
+          <a:lstStyle/>
+          <a:p>
+            <a:pPr algn="l">
+              <a:defRPr sz="1200" b="0">
+                <a:solidFill>
+                  <a:srgbClr val="AAAAAA"/>
+                </a:solidFill>
+                <a:latin typeface="Calibri Light"/>
+              </a:defRPr>
+            </a:pPr>
+            <a:r>
+              <a:t>Product Launch &amp; Corporate Activation</a:t>
+            </a:r>
+          </a:p>
+        </p:txBody>
+      </p:sp>
+      <p:sp>
+        <p:nvSpPr>
+          <p:cNvPr id="4" name="Rectangle 3"/>
           <p:cNvSpPr/>
           <p:nvPr/>
         </p:nvSpPr>
         <p:spPr>
           <a:xfrm>
-            <a:off x="731520" y="960120"/>
+            <a:off x="731520" y="1051560"/>
             <a:ext cx="1097280" cy="25400"/>
           </a:xfrm>
           <a:prstGeom prst="rect">
@@ -4443,7 +4704,43 @@
       </p:sp>
       <p:sp>
         <p:nvSpPr>
-          <p:cNvPr id="4" name="Rectangle 3"/>
+          <p:cNvPr id="5" name="TextBox 4"/>
+          <p:cNvSpPr txBox="1"/>
+          <p:nvPr/>
+        </p:nvSpPr>
+        <p:spPr>
+          <a:xfrm>
+            <a:off x="4572000" y="6446520"/>
+            <a:ext cx="6858000" cy="320040"/>
+          </a:xfrm>
+          <a:prstGeom prst="rect">
+            <a:avLst/>
+          </a:prstGeom>
+          <a:noFill/>
+        </p:spPr>
+        <p:txBody>
+          <a:bodyPr wrap="square">
+            <a:spAutoFit/>
+          </a:bodyPr>
+          <a:lstStyle/>
+          <a:p>
+            <a:pPr algn="r">
+              <a:defRPr sz="800" b="0">
+                <a:solidFill>
+                  <a:srgbClr val="555555"/>
+                </a:solidFill>
+                <a:latin typeface="Calibri Light"/>
+              </a:defRPr>
+            </a:pPr>
+            <a:r>
+              <a:t>Photos: https://drive.google.com/drive/folders/1sOueZ7NsDPiKXDulcd_UDOpesV7UUR5B</a:t>
+            </a:r>
+          </a:p>
+        </p:txBody>
+      </p:sp>
+      <p:sp>
+        <p:nvSpPr>
+          <p:cNvPr id="6" name="Rectangle 5"/>
           <p:cNvSpPr/>
           <p:nvPr/>
         </p:nvSpPr>
@@ -4494,14 +4791,14 @@
               </a:defRPr>
             </a:pPr>
             <a:r>
-              <a:t>[Wedding Photo 1]</a:t>
-            </a:r>
-          </a:p>
-        </p:txBody>
-      </p:sp>
-      <p:sp>
-        <p:nvSpPr>
-          <p:cNvPr id="5" name="Rectangle 4"/>
+              <a:t>[Brother Printer — Hero Shot]</a:t>
+            </a:r>
+          </a:p>
+        </p:txBody>
+      </p:sp>
+      <p:sp>
+        <p:nvSpPr>
+          <p:cNvPr id="7" name="Rectangle 6"/>
           <p:cNvSpPr/>
           <p:nvPr/>
         </p:nvSpPr>
@@ -4552,14 +4849,14 @@
               </a:defRPr>
             </a:pPr>
             <a:r>
-              <a:t>[Wedding Photo 2]</a:t>
-            </a:r>
-          </a:p>
-        </p:txBody>
-      </p:sp>
-      <p:sp>
-        <p:nvSpPr>
-          <p:cNvPr id="6" name="Rectangle 5"/>
+              <a:t>[Brother Printer — Detail/Product]</a:t>
+            </a:r>
+          </a:p>
+        </p:txBody>
+      </p:sp>
+      <p:sp>
+        <p:nvSpPr>
+          <p:cNvPr id="8" name="Rectangle 7"/>
           <p:cNvSpPr/>
           <p:nvPr/>
         </p:nvSpPr>
@@ -4610,7 +4907,7 @@
               </a:defRPr>
             </a:pPr>
             <a:r>
-              <a:t>[Wedding Photo 3]</a:t>
+              <a:t>[Brother Printer — Crowd/Atmosphere]</a:t>
             </a:r>
           </a:p>
         </p:txBody>
@@ -4649,7 +4946,7 @@
         </p:nvSpPr>
         <p:spPr>
           <a:xfrm>
-            <a:off x="731520" y="365760"/>
+            <a:off x="731520" y="228600"/>
             <a:ext cx="10058400" cy="548640"/>
           </a:xfrm>
           <a:prstGeom prst="rect">
@@ -4672,20 +4969,56 @@
               </a:defRPr>
             </a:pPr>
             <a:r>
-              <a:t>CORPORATE &amp; CONFERENCES</a:t>
-            </a:r>
-          </a:p>
-        </p:txBody>
-      </p:sp>
-      <p:sp>
-        <p:nvSpPr>
-          <p:cNvPr id="3" name="Rectangle 2"/>
+              <a:t>CSA</a:t>
+            </a:r>
+          </a:p>
+        </p:txBody>
+      </p:sp>
+      <p:sp>
+        <p:nvSpPr>
+          <p:cNvPr id="3" name="TextBox 2"/>
+          <p:cNvSpPr txBox="1"/>
+          <p:nvPr/>
+        </p:nvSpPr>
+        <p:spPr>
+          <a:xfrm>
+            <a:off x="731520" y="685800"/>
+            <a:ext cx="5486400" cy="365760"/>
+          </a:xfrm>
+          <a:prstGeom prst="rect">
+            <a:avLst/>
+          </a:prstGeom>
+          <a:noFill/>
+        </p:spPr>
+        <p:txBody>
+          <a:bodyPr wrap="square">
+            <a:spAutoFit/>
+          </a:bodyPr>
+          <a:lstStyle/>
+          <a:p>
+            <a:pPr algn="l">
+              <a:defRPr sz="1200" b="0">
+                <a:solidFill>
+                  <a:srgbClr val="AAAAAA"/>
+                </a:solidFill>
+                <a:latin typeface="Calibri Light"/>
+              </a:defRPr>
+            </a:pPr>
+            <a:r>
+              <a:t>Community &amp; Association Event Coverage</a:t>
+            </a:r>
+          </a:p>
+        </p:txBody>
+      </p:sp>
+      <p:sp>
+        <p:nvSpPr>
+          <p:cNvPr id="4" name="Rectangle 3"/>
           <p:cNvSpPr/>
           <p:nvPr/>
         </p:nvSpPr>
         <p:spPr>
           <a:xfrm>
-            <a:off x="731520" y="960120"/>
+            <a:off x="731520" y="1051560"/>
             <a:ext cx="1097280" cy="25400"/>
           </a:xfrm>
           <a:prstGeom prst="rect">
@@ -4722,7 +5055,43 @@
       </p:sp>
       <p:sp>
         <p:nvSpPr>
-          <p:cNvPr id="4" name="Rectangle 3"/>
+          <p:cNvPr id="5" name="TextBox 4"/>
+          <p:cNvSpPr txBox="1"/>
+          <p:nvPr/>
+        </p:nvSpPr>
+        <p:spPr>
+          <a:xfrm>
+            <a:off x="4572000" y="6446520"/>
+            <a:ext cx="6858000" cy="320040"/>
+          </a:xfrm>
+          <a:prstGeom prst="rect">
+            <a:avLst/>
+          </a:prstGeom>
+          <a:noFill/>
+        </p:spPr>
+        <p:txBody>
+          <a:bodyPr wrap="square">
+            <a:spAutoFit/>
+          </a:bodyPr>
+          <a:lstStyle/>
+          <a:p>
+            <a:pPr algn="r">
+              <a:defRPr sz="800" b="0">
+                <a:solidFill>
+                  <a:srgbClr val="555555"/>
+                </a:solidFill>
+                <a:latin typeface="Calibri Light"/>
+              </a:defRPr>
+            </a:pPr>
+            <a:r>
+              <a:t>Photos: https://drive.google.com/drive/folders/1PV_iCE1deKmjcUXjrkHLvJ5P7o-WbJsS</a:t>
+            </a:r>
+          </a:p>
+        </p:txBody>
+      </p:sp>
+      <p:sp>
+        <p:nvSpPr>
+          <p:cNvPr id="6" name="Rectangle 5"/>
           <p:cNvSpPr/>
           <p:nvPr/>
         </p:nvSpPr>
@@ -4773,14 +5142,14 @@
               </a:defRPr>
             </a:pPr>
             <a:r>
-              <a:t>[Corporate Photo 1]</a:t>
-            </a:r>
-          </a:p>
-        </p:txBody>
-      </p:sp>
-      <p:sp>
-        <p:nvSpPr>
-          <p:cNvPr id="5" name="Rectangle 4"/>
+              <a:t>[CSA — Hero Shot]</a:t>
+            </a:r>
+          </a:p>
+        </p:txBody>
+      </p:sp>
+      <p:sp>
+        <p:nvSpPr>
+          <p:cNvPr id="7" name="Rectangle 6"/>
           <p:cNvSpPr/>
           <p:nvPr/>
         </p:nvSpPr>
@@ -4831,14 +5200,14 @@
               </a:defRPr>
             </a:pPr>
             <a:r>
-              <a:t>[Corporate Photo 2]</a:t>
-            </a:r>
-          </a:p>
-        </p:txBody>
-      </p:sp>
-      <p:sp>
-        <p:nvSpPr>
-          <p:cNvPr id="6" name="Rectangle 5"/>
+              <a:t>[CSA — Keynote/Stage]</a:t>
+            </a:r>
+          </a:p>
+        </p:txBody>
+      </p:sp>
+      <p:sp>
+        <p:nvSpPr>
+          <p:cNvPr id="8" name="Rectangle 7"/>
           <p:cNvSpPr/>
           <p:nvPr/>
         </p:nvSpPr>
@@ -4889,7 +5258,7 @@
               </a:defRPr>
             </a:pPr>
             <a:r>
-              <a:t>[Corporate Photo 3]</a:t>
+              <a:t>[CSA — Guests/Networking]</a:t>
             </a:r>
           </a:p>
         </p:txBody>
@@ -4928,7 +5297,7 @@
         </p:nvSpPr>
         <p:spPr>
           <a:xfrm>
-            <a:off x="731520" y="365760"/>
+            <a:off x="731520" y="228600"/>
             <a:ext cx="10058400" cy="548640"/>
           </a:xfrm>
           <a:prstGeom prst="rect">
@@ -4951,20 +5320,56 @@
               </a:defRPr>
             </a:pPr>
             <a:r>
-              <a:t>CONCERTS &amp; ENTERTAINMENT</a:t>
-            </a:r>
-          </a:p>
-        </p:txBody>
-      </p:sp>
-      <p:sp>
-        <p:nvSpPr>
-          <p:cNvPr id="3" name="Rectangle 2"/>
+              <a:t>GY BEAUTY</a:t>
+            </a:r>
+          </a:p>
+        </p:txBody>
+      </p:sp>
+      <p:sp>
+        <p:nvSpPr>
+          <p:cNvPr id="3" name="TextBox 2"/>
+          <p:cNvSpPr txBox="1"/>
+          <p:nvPr/>
+        </p:nvSpPr>
+        <p:spPr>
+          <a:xfrm>
+            <a:off x="731520" y="685800"/>
+            <a:ext cx="5486400" cy="365760"/>
+          </a:xfrm>
+          <a:prstGeom prst="rect">
+            <a:avLst/>
+          </a:prstGeom>
+          <a:noFill/>
+        </p:spPr>
+        <p:txBody>
+          <a:bodyPr wrap="square">
+            <a:spAutoFit/>
+          </a:bodyPr>
+          <a:lstStyle/>
+          <a:p>
+            <a:pPr algn="l">
+              <a:defRPr sz="1200" b="0">
+                <a:solidFill>
+                  <a:srgbClr val="AAAAAA"/>
+                </a:solidFill>
+                <a:latin typeface="Calibri Light"/>
+              </a:defRPr>
+            </a:pPr>
+            <a:r>
+              <a:t>Beauty &amp; Lifestyle Brand Campaign</a:t>
+            </a:r>
+          </a:p>
+        </p:txBody>
+      </p:sp>
+      <p:sp>
+        <p:nvSpPr>
+          <p:cNvPr id="4" name="Rectangle 3"/>
           <p:cNvSpPr/>
           <p:nvPr/>
         </p:nvSpPr>
         <p:spPr>
           <a:xfrm>
-            <a:off x="731520" y="960120"/>
+            <a:off x="731520" y="1051560"/>
             <a:ext cx="1097280" cy="25400"/>
           </a:xfrm>
           <a:prstGeom prst="rect">
@@ -5001,7 +5406,43 @@
       </p:sp>
       <p:sp>
         <p:nvSpPr>
-          <p:cNvPr id="4" name="Rectangle 3"/>
+          <p:cNvPr id="5" name="TextBox 4"/>
+          <p:cNvSpPr txBox="1"/>
+          <p:nvPr/>
+        </p:nvSpPr>
+        <p:spPr>
+          <a:xfrm>
+            <a:off x="4572000" y="6446520"/>
+            <a:ext cx="6858000" cy="320040"/>
+          </a:xfrm>
+          <a:prstGeom prst="rect">
+            <a:avLst/>
+          </a:prstGeom>
+          <a:noFill/>
+        </p:spPr>
+        <p:txBody>
+          <a:bodyPr wrap="square">
+            <a:spAutoFit/>
+          </a:bodyPr>
+          <a:lstStyle/>
+          <a:p>
+            <a:pPr algn="r">
+              <a:defRPr sz="800" b="0">
+                <a:solidFill>
+                  <a:srgbClr val="555555"/>
+                </a:solidFill>
+                <a:latin typeface="Calibri Light"/>
+              </a:defRPr>
+            </a:pPr>
+            <a:r>
+              <a:t>Photos: https://drive.google.com/drive/folders/1ZavvJBnAlAE3VYEUXad9YDab_MNtB8qD</a:t>
+            </a:r>
+          </a:p>
+        </p:txBody>
+      </p:sp>
+      <p:sp>
+        <p:nvSpPr>
+          <p:cNvPr id="6" name="Rectangle 5"/>
           <p:cNvSpPr/>
           <p:nvPr/>
         </p:nvSpPr>
@@ -5052,14 +5493,14 @@
               </a:defRPr>
             </a:pPr>
             <a:r>
-              <a:t>[Concert Photo 1]</a:t>
-            </a:r>
-          </a:p>
-        </p:txBody>
-      </p:sp>
-      <p:sp>
-        <p:nvSpPr>
-          <p:cNvPr id="5" name="Rectangle 4"/>
+              <a:t>[GY Beauty — Hero Shot]</a:t>
+            </a:r>
+          </a:p>
+        </p:txBody>
+      </p:sp>
+      <p:sp>
+        <p:nvSpPr>
+          <p:cNvPr id="7" name="Rectangle 6"/>
           <p:cNvSpPr/>
           <p:nvPr/>
         </p:nvSpPr>
@@ -5110,14 +5551,14 @@
               </a:defRPr>
             </a:pPr>
             <a:r>
-              <a:t>[Concert Photo 2]</a:t>
-            </a:r>
-          </a:p>
-        </p:txBody>
-      </p:sp>
-      <p:sp>
-        <p:nvSpPr>
-          <p:cNvPr id="6" name="Rectangle 5"/>
+              <a:t>[GY Beauty — Product/Setup]</a:t>
+            </a:r>
+          </a:p>
+        </p:txBody>
+      </p:sp>
+      <p:sp>
+        <p:nvSpPr>
+          <p:cNvPr id="8" name="Rectangle 7"/>
           <p:cNvSpPr/>
           <p:nvPr/>
         </p:nvSpPr>
@@ -5168,7 +5609,7 @@
               </a:defRPr>
             </a:pPr>
             <a:r>
-              <a:t>[Concert Photo 3]</a:t>
+              <a:t>[GY Beauty — Candid/BTS]</a:t>
             </a:r>
           </a:p>
         </p:txBody>
@@ -5207,7 +5648,7 @@
         </p:nvSpPr>
         <p:spPr>
           <a:xfrm>
-            <a:off x="731520" y="365760"/>
+            <a:off x="731520" y="228600"/>
             <a:ext cx="10058400" cy="548640"/>
           </a:xfrm>
           <a:prstGeom prst="rect">
@@ -5230,20 +5671,56 @@
               </a:defRPr>
             </a:pPr>
             <a:r>
-              <a:t>LIFESTYLE &amp; PORTRAITS</a:t>
-            </a:r>
-          </a:p>
-        </p:txBody>
-      </p:sp>
-      <p:sp>
-        <p:nvSpPr>
-          <p:cNvPr id="3" name="Rectangle 2"/>
+              <a:t>iQIYI</a:t>
+            </a:r>
+          </a:p>
+        </p:txBody>
+      </p:sp>
+      <p:sp>
+        <p:nvSpPr>
+          <p:cNvPr id="3" name="TextBox 2"/>
+          <p:cNvSpPr txBox="1"/>
+          <p:nvPr/>
+        </p:nvSpPr>
+        <p:spPr>
+          <a:xfrm>
+            <a:off x="731520" y="685800"/>
+            <a:ext cx="5486400" cy="365760"/>
+          </a:xfrm>
+          <a:prstGeom prst="rect">
+            <a:avLst/>
+          </a:prstGeom>
+          <a:noFill/>
+        </p:spPr>
+        <p:txBody>
+          <a:bodyPr wrap="square">
+            <a:spAutoFit/>
+          </a:bodyPr>
+          <a:lstStyle/>
+          <a:p>
+            <a:pPr algn="l">
+              <a:defRPr sz="1200" b="0">
+                <a:solidFill>
+                  <a:srgbClr val="AAAAAA"/>
+                </a:solidFill>
+                <a:latin typeface="Calibri Light"/>
+              </a:defRPr>
+            </a:pPr>
+            <a:r>
+              <a:t>Entertainment Premiere &amp; Press Conference</a:t>
+            </a:r>
+          </a:p>
+        </p:txBody>
+      </p:sp>
+      <p:sp>
+        <p:nvSpPr>
+          <p:cNvPr id="4" name="Rectangle 3"/>
           <p:cNvSpPr/>
           <p:nvPr/>
         </p:nvSpPr>
         <p:spPr>
           <a:xfrm>
-            <a:off x="731520" y="960120"/>
+            <a:off x="731520" y="1051560"/>
             <a:ext cx="1097280" cy="25400"/>
           </a:xfrm>
           <a:prstGeom prst="rect">
@@ -5280,7 +5757,43 @@
       </p:sp>
       <p:sp>
         <p:nvSpPr>
-          <p:cNvPr id="4" name="Rectangle 3"/>
+          <p:cNvPr id="5" name="TextBox 4"/>
+          <p:cNvSpPr txBox="1"/>
+          <p:nvPr/>
+        </p:nvSpPr>
+        <p:spPr>
+          <a:xfrm>
+            <a:off x="4572000" y="6446520"/>
+            <a:ext cx="6858000" cy="320040"/>
+          </a:xfrm>
+          <a:prstGeom prst="rect">
+            <a:avLst/>
+          </a:prstGeom>
+          <a:noFill/>
+        </p:spPr>
+        <p:txBody>
+          <a:bodyPr wrap="square">
+            <a:spAutoFit/>
+          </a:bodyPr>
+          <a:lstStyle/>
+          <a:p>
+            <a:pPr algn="r">
+              <a:defRPr sz="800" b="0">
+                <a:solidFill>
+                  <a:srgbClr val="555555"/>
+                </a:solidFill>
+                <a:latin typeface="Calibri Light"/>
+              </a:defRPr>
+            </a:pPr>
+            <a:r>
+              <a:t>Photos: https://drive.google.com/drive/folders/1YZFnxhfwNfhpQB7a-UHRkbVwSxcJqUdd</a:t>
+            </a:r>
+          </a:p>
+        </p:txBody>
+      </p:sp>
+      <p:sp>
+        <p:nvSpPr>
+          <p:cNvPr id="6" name="Rectangle 5"/>
           <p:cNvSpPr/>
           <p:nvPr/>
         </p:nvSpPr>
@@ -5331,14 +5844,14 @@
               </a:defRPr>
             </a:pPr>
             <a:r>
-              <a:t>[Lifestyle Photo 1]</a:t>
-            </a:r>
-          </a:p>
-        </p:txBody>
-      </p:sp>
-      <p:sp>
-        <p:nvSpPr>
-          <p:cNvPr id="5" name="Rectangle 4"/>
+              <a:t>[iQiYi — Hero Shot]</a:t>
+            </a:r>
+          </a:p>
+        </p:txBody>
+      </p:sp>
+      <p:sp>
+        <p:nvSpPr>
+          <p:cNvPr id="7" name="Rectangle 6"/>
           <p:cNvSpPr/>
           <p:nvPr/>
         </p:nvSpPr>
@@ -5389,14 +5902,14 @@
               </a:defRPr>
             </a:pPr>
             <a:r>
-              <a:t>[Lifestyle Photo 2]</a:t>
-            </a:r>
-          </a:p>
-        </p:txBody>
-      </p:sp>
-      <p:sp>
-        <p:nvSpPr>
-          <p:cNvPr id="6" name="Rectangle 5"/>
+              <a:t>[iQiYi — Stage/Red Carpet]</a:t>
+            </a:r>
+          </a:p>
+        </p:txBody>
+      </p:sp>
+      <p:sp>
+        <p:nvSpPr>
+          <p:cNvPr id="8" name="Rectangle 7"/>
           <p:cNvSpPr/>
           <p:nvPr/>
         </p:nvSpPr>
@@ -5447,7 +5960,7 @@
               </a:defRPr>
             </a:pPr>
             <a:r>
-              <a:t>[Lifestyle Photo 3]</a:t>
+              <a:t>[iQiYi — Press/Media]</a:t>
             </a:r>
           </a:p>
         </p:txBody>
@@ -5461,6 +5974,357 @@
 </file>
 
 <file path=ppt/slides/slide8.xml><?xml version="1.0" encoding="utf-8"?>
+<p:sld xmlns:a="http://schemas.openxmlformats.org/drawingml/2006/main" xmlns:p="http://schemas.openxmlformats.org/presentationml/2006/main" xmlns:r="http://schemas.openxmlformats.org/officeDocument/2006/relationships">
+  <p:cSld>
+    <p:bg>
+      <p:bgPr>
+        <a:solidFill>
+          <a:srgbClr val="1A1A1A"/>
+        </a:solidFill>
+        <a:effectLst/>
+      </p:bgPr>
+    </p:bg>
+    <p:spTree>
+      <p:nvGrpSpPr>
+        <p:cNvPr id="1" name=""/>
+        <p:cNvGrpSpPr/>
+        <p:nvPr/>
+      </p:nvGrpSpPr>
+      <p:grpSpPr/>
+      <p:sp>
+        <p:nvSpPr>
+          <p:cNvPr id="2" name="TextBox 1"/>
+          <p:cNvSpPr txBox="1"/>
+          <p:nvPr/>
+        </p:nvSpPr>
+        <p:spPr>
+          <a:xfrm>
+            <a:off x="731520" y="228600"/>
+            <a:ext cx="10058400" cy="548640"/>
+          </a:xfrm>
+          <a:prstGeom prst="rect">
+            <a:avLst/>
+          </a:prstGeom>
+          <a:noFill/>
+        </p:spPr>
+        <p:txBody>
+          <a:bodyPr wrap="square">
+            <a:spAutoFit/>
+          </a:bodyPr>
+          <a:lstStyle/>
+          <a:p>
+            <a:pPr algn="l">
+              <a:defRPr sz="2200" b="1">
+                <a:solidFill>
+                  <a:srgbClr val="C8A26E"/>
+                </a:solidFill>
+                <a:latin typeface="Calibri Light"/>
+              </a:defRPr>
+            </a:pPr>
+            <a:r>
+              <a:t>ZONTES</a:t>
+            </a:r>
+          </a:p>
+        </p:txBody>
+      </p:sp>
+      <p:sp>
+        <p:nvSpPr>
+          <p:cNvPr id="3" name="TextBox 2"/>
+          <p:cNvSpPr txBox="1"/>
+          <p:nvPr/>
+        </p:nvSpPr>
+        <p:spPr>
+          <a:xfrm>
+            <a:off x="731520" y="685800"/>
+            <a:ext cx="5486400" cy="365760"/>
+          </a:xfrm>
+          <a:prstGeom prst="rect">
+            <a:avLst/>
+          </a:prstGeom>
+          <a:noFill/>
+        </p:spPr>
+        <p:txBody>
+          <a:bodyPr wrap="square">
+            <a:spAutoFit/>
+          </a:bodyPr>
+          <a:lstStyle/>
+          <a:p>
+            <a:pPr algn="l">
+              <a:defRPr sz="1200" b="0">
+                <a:solidFill>
+                  <a:srgbClr val="AAAAAA"/>
+                </a:solidFill>
+                <a:latin typeface="Calibri Light"/>
+              </a:defRPr>
+            </a:pPr>
+            <a:r>
+              <a:t>Automotive Launch &amp; Brand Activation</a:t>
+            </a:r>
+          </a:p>
+        </p:txBody>
+      </p:sp>
+      <p:sp>
+        <p:nvSpPr>
+          <p:cNvPr id="4" name="Rectangle 3"/>
+          <p:cNvSpPr/>
+          <p:nvPr/>
+        </p:nvSpPr>
+        <p:spPr>
+          <a:xfrm>
+            <a:off x="731520" y="1051560"/>
+            <a:ext cx="1097280" cy="25400"/>
+          </a:xfrm>
+          <a:prstGeom prst="rect">
+            <a:avLst/>
+          </a:prstGeom>
+          <a:solidFill>
+            <a:srgbClr val="C8A26E"/>
+          </a:solidFill>
+          <a:ln>
+            <a:noFill/>
+          </a:ln>
+        </p:spPr>
+        <p:style>
+          <a:lnRef idx="1">
+            <a:schemeClr val="accent1"/>
+          </a:lnRef>
+          <a:fillRef idx="3">
+            <a:schemeClr val="accent1"/>
+          </a:fillRef>
+          <a:effectRef idx="2">
+            <a:schemeClr val="accent1"/>
+          </a:effectRef>
+          <a:fontRef idx="minor">
+            <a:schemeClr val="lt1"/>
+          </a:fontRef>
+        </p:style>
+        <p:txBody>
+          <a:bodyPr rtlCol="0" anchor="ctr"/>
+          <a:lstStyle/>
+          <a:p>
+            <a:pPr algn="ctr"/>
+          </a:p>
+        </p:txBody>
+      </p:sp>
+      <p:sp>
+        <p:nvSpPr>
+          <p:cNvPr id="5" name="TextBox 4"/>
+          <p:cNvSpPr txBox="1"/>
+          <p:nvPr/>
+        </p:nvSpPr>
+        <p:spPr>
+          <a:xfrm>
+            <a:off x="4572000" y="6446520"/>
+            <a:ext cx="6858000" cy="320040"/>
+          </a:xfrm>
+          <a:prstGeom prst="rect">
+            <a:avLst/>
+          </a:prstGeom>
+          <a:noFill/>
+        </p:spPr>
+        <p:txBody>
+          <a:bodyPr wrap="square">
+            <a:spAutoFit/>
+          </a:bodyPr>
+          <a:lstStyle/>
+          <a:p>
+            <a:pPr algn="r">
+              <a:defRPr sz="800" b="0">
+                <a:solidFill>
+                  <a:srgbClr val="555555"/>
+                </a:solidFill>
+                <a:latin typeface="Calibri Light"/>
+              </a:defRPr>
+            </a:pPr>
+            <a:r>
+              <a:t>Photos: https://drive.google.com/drive/folders/1m-A4gOP2gv-XInpkl_Z28aHM7exuRRpd</a:t>
+            </a:r>
+          </a:p>
+        </p:txBody>
+      </p:sp>
+      <p:sp>
+        <p:nvSpPr>
+          <p:cNvPr id="6" name="Rectangle 5"/>
+          <p:cNvSpPr/>
+          <p:nvPr/>
+        </p:nvSpPr>
+        <p:spPr>
+          <a:xfrm>
+            <a:off x="731520" y="1280160"/>
+            <a:ext cx="6400800" cy="5029200"/>
+          </a:xfrm>
+          <a:prstGeom prst="rect">
+            <a:avLst/>
+          </a:prstGeom>
+          <a:solidFill>
+            <a:srgbClr val="2A2A2A"/>
+          </a:solidFill>
+          <a:ln w="12700">
+            <a:solidFill>
+              <a:srgbClr val="444444"/>
+            </a:solidFill>
+          </a:ln>
+        </p:spPr>
+        <p:style>
+          <a:lnRef idx="1">
+            <a:schemeClr val="accent1"/>
+          </a:lnRef>
+          <a:fillRef idx="3">
+            <a:schemeClr val="accent1"/>
+          </a:fillRef>
+          <a:effectRef idx="2">
+            <a:schemeClr val="accent1"/>
+          </a:effectRef>
+          <a:fontRef idx="minor">
+            <a:schemeClr val="lt1"/>
+          </a:fontRef>
+        </p:style>
+        <p:txBody>
+          <a:bodyPr rtlCol="0" anchor="ctr" wrap="square"/>
+          <a:lstStyle/>
+          <a:p>
+            <a:pPr algn="ctr">
+              <a:spcBef>
+                <a:spcPts val="0"/>
+              </a:spcBef>
+              <a:defRPr sz="1100">
+                <a:solidFill>
+                  <a:srgbClr val="AAAAAA"/>
+                </a:solidFill>
+                <a:latin typeface="Calibri Light"/>
+              </a:defRPr>
+            </a:pPr>
+            <a:r>
+              <a:t>[Zontes — Hero Shot]</a:t>
+            </a:r>
+          </a:p>
+        </p:txBody>
+      </p:sp>
+      <p:sp>
+        <p:nvSpPr>
+          <p:cNvPr id="7" name="Rectangle 6"/>
+          <p:cNvSpPr/>
+          <p:nvPr/>
+        </p:nvSpPr>
+        <p:spPr>
+          <a:xfrm>
+            <a:off x="7406640" y="1280160"/>
+            <a:ext cx="4023360" cy="2377440"/>
+          </a:xfrm>
+          <a:prstGeom prst="rect">
+            <a:avLst/>
+          </a:prstGeom>
+          <a:solidFill>
+            <a:srgbClr val="2A2A2A"/>
+          </a:solidFill>
+          <a:ln w="12700">
+            <a:solidFill>
+              <a:srgbClr val="444444"/>
+            </a:solidFill>
+          </a:ln>
+        </p:spPr>
+        <p:style>
+          <a:lnRef idx="1">
+            <a:schemeClr val="accent1"/>
+          </a:lnRef>
+          <a:fillRef idx="3">
+            <a:schemeClr val="accent1"/>
+          </a:fillRef>
+          <a:effectRef idx="2">
+            <a:schemeClr val="accent1"/>
+          </a:effectRef>
+          <a:fontRef idx="minor">
+            <a:schemeClr val="lt1"/>
+          </a:fontRef>
+        </p:style>
+        <p:txBody>
+          <a:bodyPr rtlCol="0" anchor="ctr" wrap="square"/>
+          <a:lstStyle/>
+          <a:p>
+            <a:pPr algn="ctr">
+              <a:spcBef>
+                <a:spcPts val="0"/>
+              </a:spcBef>
+              <a:defRPr sz="1100">
+                <a:solidFill>
+                  <a:srgbClr val="AAAAAA"/>
+                </a:solidFill>
+                <a:latin typeface="Calibri Light"/>
+              </a:defRPr>
+            </a:pPr>
+            <a:r>
+              <a:t>[Zontes — Product/Bike]</a:t>
+            </a:r>
+          </a:p>
+        </p:txBody>
+      </p:sp>
+      <p:sp>
+        <p:nvSpPr>
+          <p:cNvPr id="8" name="Rectangle 7"/>
+          <p:cNvSpPr/>
+          <p:nvPr/>
+        </p:nvSpPr>
+        <p:spPr>
+          <a:xfrm>
+            <a:off x="7406640" y="3931920"/>
+            <a:ext cx="4023360" cy="2377440"/>
+          </a:xfrm>
+          <a:prstGeom prst="rect">
+            <a:avLst/>
+          </a:prstGeom>
+          <a:solidFill>
+            <a:srgbClr val="2A2A2A"/>
+          </a:solidFill>
+          <a:ln w="12700">
+            <a:solidFill>
+              <a:srgbClr val="444444"/>
+            </a:solidFill>
+          </a:ln>
+        </p:spPr>
+        <p:style>
+          <a:lnRef idx="1">
+            <a:schemeClr val="accent1"/>
+          </a:lnRef>
+          <a:fillRef idx="3">
+            <a:schemeClr val="accent1"/>
+          </a:fillRef>
+          <a:effectRef idx="2">
+            <a:schemeClr val="accent1"/>
+          </a:effectRef>
+          <a:fontRef idx="minor">
+            <a:schemeClr val="lt1"/>
+          </a:fontRef>
+        </p:style>
+        <p:txBody>
+          <a:bodyPr rtlCol="0" anchor="ctr" wrap="square"/>
+          <a:lstStyle/>
+          <a:p>
+            <a:pPr algn="ctr">
+              <a:spcBef>
+                <a:spcPts val="0"/>
+              </a:spcBef>
+              <a:defRPr sz="1100">
+                <a:solidFill>
+                  <a:srgbClr val="AAAAAA"/>
+                </a:solidFill>
+                <a:latin typeface="Calibri Light"/>
+              </a:defRPr>
+            </a:pPr>
+            <a:r>
+              <a:t>[Zontes — Action/Crowd]</a:t>
+            </a:r>
+          </a:p>
+        </p:txBody>
+      </p:sp>
+    </p:spTree>
+  </p:cSld>
+  <p:clrMapOvr>
+    <a:masterClrMapping/>
+  </p:clrMapOvr>
+</p:sld>
+</file>
+
+<file path=ppt/slides/slide9.xml><?xml version="1.0" encoding="utf-8"?>
 <p:sld xmlns:a="http://schemas.openxmlformats.org/drawingml/2006/main" xmlns:p="http://schemas.openxmlformats.org/presentationml/2006/main" xmlns:r="http://schemas.openxmlformats.org/officeDocument/2006/relationships">
   <p:cSld>
     <p:bg>
@@ -5841,176 +6705,6 @@
             </a:pPr>
             <a:r>
               <a:t>Years of Experience</a:t>
-            </a:r>
-          </a:p>
-        </p:txBody>
-      </p:sp>
-    </p:spTree>
-  </p:cSld>
-  <p:clrMapOvr>
-    <a:masterClrMapping/>
-  </p:clrMapOvr>
-</p:sld>
-</file>
-
-<file path=ppt/slides/slide9.xml><?xml version="1.0" encoding="utf-8"?>
-<p:sld xmlns:a="http://schemas.openxmlformats.org/drawingml/2006/main" xmlns:p="http://schemas.openxmlformats.org/presentationml/2006/main" xmlns:r="http://schemas.openxmlformats.org/officeDocument/2006/relationships">
-  <p:cSld>
-    <p:bg>
-      <p:bgPr>
-        <a:solidFill>
-          <a:srgbClr val="1A1A1A"/>
-        </a:solidFill>
-        <a:effectLst/>
-      </p:bgPr>
-    </p:bg>
-    <p:spTree>
-      <p:nvGrpSpPr>
-        <p:cNvPr id="1" name=""/>
-        <p:cNvGrpSpPr/>
-        <p:nvPr/>
-      </p:nvGrpSpPr>
-      <p:grpSpPr/>
-      <p:sp>
-        <p:nvSpPr>
-          <p:cNvPr id="2" name="TextBox 1"/>
-          <p:cNvSpPr txBox="1"/>
-          <p:nvPr/>
-        </p:nvSpPr>
-        <p:spPr>
-          <a:xfrm>
-            <a:off x="914400" y="914400"/>
-            <a:ext cx="914400" cy="1371600"/>
-          </a:xfrm>
-          <a:prstGeom prst="rect">
-            <a:avLst/>
-          </a:prstGeom>
-          <a:noFill/>
-        </p:spPr>
-        <p:txBody>
-          <a:bodyPr wrap="square">
-            <a:spAutoFit/>
-          </a:bodyPr>
-          <a:lstStyle/>
-          <a:p>
-            <a:pPr algn="l">
-              <a:defRPr sz="9600" b="1">
-                <a:solidFill>
-                  <a:srgbClr val="C8A26E"/>
-                </a:solidFill>
-                <a:latin typeface="Calibri Light"/>
-              </a:defRPr>
-            </a:pPr>
-            <a:r>
-              <a:t>“</a:t>
-            </a:r>
-          </a:p>
-        </p:txBody>
-      </p:sp>
-      <p:sp>
-        <p:nvSpPr>
-          <p:cNvPr id="3" name="TextBox 2"/>
-          <p:cNvSpPr txBox="1"/>
-          <p:nvPr/>
-        </p:nvSpPr>
-        <p:spPr>
-          <a:xfrm>
-            <a:off x="1828800" y="2011680"/>
-            <a:ext cx="8229600" cy="2286000"/>
-          </a:xfrm>
-          <a:prstGeom prst="rect">
-            <a:avLst/>
-          </a:prstGeom>
-          <a:noFill/>
-        </p:spPr>
-        <p:txBody>
-          <a:bodyPr wrap="square">
-            <a:spAutoFit/>
-          </a:bodyPr>
-          <a:lstStyle/>
-          <a:p>
-            <a:pPr algn="ctr">
-              <a:defRPr sz="2000" b="0">
-                <a:solidFill>
-                  <a:srgbClr val="FFFFFF"/>
-                </a:solidFill>
-                <a:latin typeface="Calibri Light"/>
-              </a:defRPr>
-            </a:pPr>
-            <a:r>
-              <a:t>Absolutely phenomenal work. Every single photo captured the energy and emotion of our event perfectly. We couldn't have asked for a better photographer. Highly recommend!</a:t>
-            </a:r>
-          </a:p>
-        </p:txBody>
-      </p:sp>
-      <p:sp>
-        <p:nvSpPr>
-          <p:cNvPr id="4" name="TextBox 3"/>
-          <p:cNvSpPr txBox="1"/>
-          <p:nvPr/>
-        </p:nvSpPr>
-        <p:spPr>
-          <a:xfrm>
-            <a:off x="1828800" y="4389120"/>
-            <a:ext cx="8229600" cy="457200"/>
-          </a:xfrm>
-          <a:prstGeom prst="rect">
-            <a:avLst/>
-          </a:prstGeom>
-          <a:noFill/>
-        </p:spPr>
-        <p:txBody>
-          <a:bodyPr wrap="square">
-            <a:spAutoFit/>
-          </a:bodyPr>
-          <a:lstStyle/>
-          <a:p>
-            <a:pPr algn="ctr">
-              <a:defRPr sz="1400" b="0">
-                <a:solidFill>
-                  <a:srgbClr val="AAAAAA"/>
-                </a:solidFill>
-                <a:latin typeface="Calibri Light"/>
-              </a:defRPr>
-            </a:pPr>
-            <a:r>
-              <a:t>— [Client Name], [Event Name]</a:t>
-            </a:r>
-          </a:p>
-        </p:txBody>
-      </p:sp>
-      <p:sp>
-        <p:nvSpPr>
-          <p:cNvPr id="5" name="TextBox 4"/>
-          <p:cNvSpPr txBox="1"/>
-          <p:nvPr/>
-        </p:nvSpPr>
-        <p:spPr>
-          <a:xfrm>
-            <a:off x="1828800" y="5303520"/>
-            <a:ext cx="8229600" cy="365760"/>
-          </a:xfrm>
-          <a:prstGeom prst="rect">
-            <a:avLst/>
-          </a:prstGeom>
-          <a:noFill/>
-        </p:spPr>
-        <p:txBody>
-          <a:bodyPr wrap="square">
-            <a:spAutoFit/>
-          </a:bodyPr>
-          <a:lstStyle/>
-          <a:p>
-            <a:pPr algn="ctr">
-              <a:defRPr sz="1100" b="0">
-                <a:solidFill>
-                  <a:srgbClr val="555555"/>
-                </a:solidFill>
-                <a:latin typeface="Calibri Light"/>
-              </a:defRPr>
-            </a:pPr>
-            <a:r>
-              <a:t>[Add more testimonials as needed]</a:t>
             </a:r>
           </a:p>
         </p:txBody>

</xml_diff>